<commit_message>
docs: relabel persona decks as product vision (not shipped)
Per the panel finding that the decks pitch specced-not-shipped features present-
tense (ADR-029 Proposed/zero-code; ADR-033 gated on managed billing), add a clear
'◆ PRODUCT VISION' banner to every deck's title slide and every web artifact:
'a preview of where Mentible is headed; the grounded AI and private hosted sync
shown here are on the roadmap (ADR-029/033), not yet shipped.'

Keeps the first-person narrative (the voice/appeal) but removes the implication
that these features exist today. Decks README gains a Status: product-vision note.
4 artifacts re-published to the same URLs; repo HTML re-wrapped; all decks
regenerated + the physician title spot-checked.

Co-Authored-By: Claude Opus 4.8 (1M context) <noreply@anthropic.com>
</commit_message>
<xml_diff>
--- a/docs/adr-033-decks/mentible-for-medical-students.pptx
+++ b/docs/adr-033-decks/mentible-for-medical-students.pptx
@@ -4790,6 +4790,102 @@
                 <a:latin typeface="Calibri"/>
               </a:rPr>
               <a:t>  ·  second-year medical student</a:t>
+            </a:r>
+          </a:p>
+        </p:txBody>
+      </p:sp>
+      <p:sp>
+        <p:nvSpPr>
+          <p:cNvPr id="41" name="Rounded Rectangle 40"/>
+          <p:cNvSpPr/>
+          <p:nvPr/>
+        </p:nvSpPr>
+        <p:spPr>
+          <a:xfrm>
+            <a:off x="1417320" y="6126480"/>
+            <a:ext cx="10058400" cy="502920"/>
+          </a:xfrm>
+          <a:prstGeom prst="roundRect">
+            <a:avLst>
+              <a:gd name="adj" fmla="val 30000"/>
+            </a:avLst>
+          </a:prstGeom>
+          <a:solidFill>
+            <a:srgbClr val="E6F1EB"/>
+          </a:solidFill>
+          <a:ln w="12700">
+            <a:solidFill>
+              <a:srgbClr val="BFDDCB"/>
+            </a:solidFill>
+          </a:ln>
+          <a:effectLst/>
+        </p:spPr>
+        <p:style>
+          <a:lnRef idx="1">
+            <a:schemeClr val="accent1"/>
+          </a:lnRef>
+          <a:fillRef idx="3">
+            <a:schemeClr val="accent1"/>
+          </a:fillRef>
+          <a:effectRef idx="2">
+            <a:schemeClr val="accent1"/>
+          </a:effectRef>
+          <a:fontRef idx="minor">
+            <a:schemeClr val="lt1"/>
+          </a:fontRef>
+        </p:style>
+        <p:txBody>
+          <a:bodyPr rtlCol="0" anchor="ctr"/>
+          <a:lstStyle/>
+          <a:p>
+            <a:pPr algn="ctr"/>
+          </a:p>
+        </p:txBody>
+      </p:sp>
+      <p:sp>
+        <p:nvSpPr>
+          <p:cNvPr id="42" name="TextBox 41"/>
+          <p:cNvSpPr txBox="1"/>
+          <p:nvPr/>
+        </p:nvSpPr>
+        <p:spPr>
+          <a:xfrm>
+            <a:off x="1691640" y="6126480"/>
+            <a:ext cx="9601200" cy="502920"/>
+          </a:xfrm>
+          <a:prstGeom prst="rect">
+            <a:avLst/>
+          </a:prstGeom>
+          <a:noFill/>
+        </p:spPr>
+        <p:txBody>
+          <a:bodyPr wrap="square" anchor="ctr" lIns="0" rIns="0" tIns="0" bIns="0">
+            <a:spAutoFit/>
+          </a:bodyPr>
+          <a:lstStyle/>
+          <a:p>
+            <a:pPr algn="l">
+              <a:spcAft>
+                <a:spcPts val="0"/>
+              </a:spcAft>
+            </a:pPr>
+            <a:r>
+              <a:rPr sz="1050" b="1" i="0">
+                <a:solidFill>
+                  <a:srgbClr val="2E7D5B"/>
+                </a:solidFill>
+                <a:latin typeface="Consolas"/>
+              </a:rPr>
+              <a:t>◆ PRODUCT VISION — </a:t>
+            </a:r>
+            <a:r>
+              <a:rPr sz="1050" b="0" i="0">
+                <a:solidFill>
+                  <a:srgbClr val="21302B"/>
+                </a:solidFill>
+                <a:latin typeface="Calibri"/>
+              </a:rPr>
+              <a:t>a preview of where Mentible is headed. The grounded AI and private hosted sync shown here are on the roadmap (ADR-029/033), not yet shipped.</a:t>
             </a:r>
           </a:p>
         </p:txBody>

</xml_diff>